<commit_message>
turned to fluter app
</commit_message>
<xml_diff>
--- a/Kahawa_Roots_Pre_Interview_Task_my_approach.pptx
+++ b/Kahawa_Roots_Pre_Interview_Task_my_approach.pptx
@@ -188,7 +188,7 @@
           <a:p>
             <a:fld id="{1D8BD707-D9CF-40AE-B4C6-C98DA3205C09}" type="datetimeFigureOut">
               <a:rPr lang="en-US"/>
-              <a:t>4/12/26</a:t>
+              <a:t>4/21/26</a:t>
             </a:fld>
             <a:endParaRPr lang="en-US"/>
           </a:p>
@@ -374,7 +374,7 @@
           <a:p>
             <a:fld id="{1D8BD707-D9CF-40AE-B4C6-C98DA3205C09}" type="datetimeFigureOut">
               <a:rPr lang="en-US"/>
-              <a:t>4/12/26</a:t>
+              <a:t>4/21/26</a:t>
             </a:fld>
             <a:endParaRPr lang="en-US"/>
           </a:p>
@@ -601,7 +601,7 @@
           <a:p>
             <a:fld id="{1D8BD707-D9CF-40AE-B4C6-C98DA3205C09}" type="datetimeFigureOut">
               <a:rPr lang="en-US"/>
-              <a:t>4/12/26</a:t>
+              <a:t>4/21/26</a:t>
             </a:fld>
             <a:endParaRPr lang="en-US"/>
           </a:p>
@@ -758,7 +758,7 @@
           <a:p>
             <a:fld id="{1D8BD707-D9CF-40AE-B4C6-C98DA3205C09}" type="datetimeFigureOut">
               <a:rPr lang="en-US"/>
-              <a:t>4/12/26</a:t>
+              <a:t>4/21/26</a:t>
             </a:fld>
             <a:endParaRPr lang="en-US"/>
           </a:p>
@@ -886,7 +886,7 @@
           <a:p>
             <a:fld id="{1D8BD707-D9CF-40AE-B4C6-C98DA3205C09}" type="datetimeFigureOut">
               <a:rPr lang="en-US"/>
-              <a:t>4/12/26</a:t>
+              <a:t>4/21/26</a:t>
             </a:fld>
             <a:endParaRPr lang="en-US"/>
           </a:p>
@@ -1170,7 +1170,7 @@
           <a:p>
             <a:fld id="{1D8BD707-D9CF-40AE-B4C6-C98DA3205C09}" type="datetimeFigureOut">
               <a:rPr lang="en-US"/>
-              <a:t>4/12/26</a:t>
+              <a:t>4/21/26</a:t>
             </a:fld>
             <a:endParaRPr lang="en-US"/>
           </a:p>
@@ -7801,27 +7801,7 @@
                 <a:latin typeface="Arial MT"/>
                 <a:cs typeface="Arial MT"/>
               </a:rPr>
-              <a:t>Pay only for run, no cost when idle</a:t>
-            </a:r>
-            <a:r>
-              <a:rPr sz="800" dirty="0">
-                <a:solidFill>
-                  <a:srgbClr val="333333"/>
-                </a:solidFill>
-                <a:latin typeface="Arial MT"/>
-                <a:cs typeface="Arial MT"/>
-              </a:rPr>
-              <a:t>. </a:t>
-            </a:r>
-            <a:r>
-              <a:rPr lang="en-US" sz="800" dirty="0">
-                <a:solidFill>
-                  <a:srgbClr val="333333"/>
-                </a:solidFill>
-                <a:latin typeface="Arial MT"/>
-                <a:cs typeface="Arial MT"/>
-              </a:rPr>
-              <a:t>No idle infrastructure costs.</a:t>
+              <a:t>Pay only for run, no cost when idle.</a:t>
             </a:r>
             <a:endParaRPr lang="en-US" sz="800" dirty="0">
               <a:latin typeface="Arial MT"/>
@@ -8691,24 +8671,54 @@
                 <a:latin typeface="Arial MT"/>
                 <a:cs typeface="Arial MT"/>
               </a:rPr>
-              <a:t> (europe-west2). Data stays in the UK,</a:t>
-            </a:r>
-            <a:r>
-              <a:rPr lang="en-US" sz="800" dirty="0">
+              <a:t> (europe-west2). Data stays in the UK</a:t>
+            </a:r>
+            <a:r>
+              <a:rPr sz="800">
+                <a:solidFill>
+                  <a:srgbClr val="333333"/>
+                </a:solidFill>
+                <a:latin typeface="Arial MT"/>
+                <a:cs typeface="Arial MT"/>
+              </a:rPr>
+              <a:t>,</a:t>
+            </a:r>
+            <a:r>
+              <a:rPr lang="en-US" sz="800">
                 <a:latin typeface="Arial MT"/>
                 <a:cs typeface="Arial MT"/>
               </a:rPr>
               <a:t> </a:t>
             </a:r>
             <a:r>
-              <a:rPr sz="800" dirty="0">
-                <a:solidFill>
-                  <a:srgbClr val="333333"/>
-                </a:solidFill>
-                <a:latin typeface="Arial MT"/>
-                <a:cs typeface="Arial MT"/>
-              </a:rPr>
-              <a:t>GDPR</a:t>
+              <a:rPr sz="800">
+                <a:solidFill>
+                  <a:srgbClr val="333333"/>
+                </a:solidFill>
+                <a:latin typeface="Arial MT"/>
+                <a:cs typeface="Arial MT"/>
+              </a:rPr>
+              <a:t>G</a:t>
+            </a:r>
+            <a:r>
+              <a:rPr lang="en-US" sz="800">
+                <a:solidFill>
+                  <a:srgbClr val="333333"/>
+                </a:solidFill>
+                <a:latin typeface="Arial MT"/>
+                <a:cs typeface="Arial MT"/>
+              </a:rPr>
+              <a:t>π</a:t>
+            </a:r>
+            <a:r>
+              <a:rPr sz="800">
+                <a:solidFill>
+                  <a:srgbClr val="333333"/>
+                </a:solidFill>
+                <a:latin typeface="Arial MT"/>
+                <a:cs typeface="Arial MT"/>
+              </a:rPr>
+              <a:t>DPR</a:t>
             </a:r>
             <a:r>
               <a:rPr lang="en-IN" sz="800" dirty="0">

</xml_diff>